<commit_message>
Commit on 21 May 2026 , 12:37 PM
</commit_message>
<xml_diff>
--- a/Protocol_Fuzzer_Presentation.pptx
+++ b/Protocol_Fuzzer_Presentation.pptx
@@ -5,16 +5,15 @@
     <p:sldMasterId id="2147483840" r:id="rId1"/>
   </p:sldMasterIdLst>
   <p:sldIdLst>
-    <p:sldId id="256" r:id="rId2"/>
-    <p:sldId id="257" r:id="rId7"/>
-    <p:sldId id="258" r:id="rId8"/>
-    <p:sldId id="259" r:id="rId9"/>
-    <p:sldId id="260" r:id="rId10"/>
-    <p:sldId id="261" r:id="rId11"/>
-    <p:sldId id="262" r:id="rId12"/>
-    <p:sldId id="263" r:id="rId13"/>
-    <p:sldId id="264" r:id="rId14"/>
-    <p:sldId id="265" r:id="rId15"/>
+    <p:sldId id="257" r:id="rId2"/>
+    <p:sldId id="258" r:id="rId3"/>
+    <p:sldId id="259" r:id="rId4"/>
+    <p:sldId id="260" r:id="rId5"/>
+    <p:sldId id="261" r:id="rId6"/>
+    <p:sldId id="262" r:id="rId7"/>
+    <p:sldId id="263" r:id="rId8"/>
+    <p:sldId id="264" r:id="rId9"/>
+    <p:sldId id="265" r:id="rId10"/>
   </p:sldIdLst>
   <p:sldSz cx="12192000" cy="6858000"/>
   <p:notesSz cx="6858000" cy="9144000"/>
@@ -113,6 +112,11 @@
       </a:defRPr>
     </a:lvl9pPr>
   </p:defaultTextStyle>
+  <p:extLst>
+    <p:ext uri="{EFAFB233-063F-42B5-8137-9DF3F51BA10A}">
+      <p15:sldGuideLst xmlns:p15="http://schemas.microsoft.com/office/powerpoint/2012/main"/>
+    </p:ext>
+  </p:extLst>
 </p:presentation>
 </file>
 
@@ -3444,141 +3448,185 @@
       </p:grpSpPr>
       <p:sp>
         <p:nvSpPr>
-          <p:cNvPr id="2" name="Title 1">
+          <p:cNvPr id="2" name="Title 1"/>
+          <p:cNvSpPr>
+            <a:spLocks noGrp="1"/>
+          </p:cNvSpPr>
+          <p:nvPr>
+            <p:ph type="ctrTitle"/>
+          </p:nvPr>
+        </p:nvSpPr>
+        <p:spPr>
+          <a:xfrm>
+            <a:off x="1080060" y="1471201"/>
+            <a:ext cx="7315200" cy="2276179"/>
+          </a:xfrm>
+        </p:spPr>
+        <p:txBody>
+          <a:bodyPr/>
+          <a:lstStyle/>
+          <a:p>
+            <a:r>
+              <a:t>Ad</a:t>
+            </a:r>
+            <a:r>
+              <a:rPr lang="en-US"/>
+              <a:t>vanced </a:t>
+            </a:r>
+            <a:r>
+              <a:t>Protocol Fuzzing </a:t>
+            </a:r>
+            <a:r>
+              <a:rPr lang="en-US"/>
+              <a:t>Framework</a:t>
+            </a:r>
+            <a:endParaRPr/>
+          </a:p>
+        </p:txBody>
+      </p:sp>
+      <p:sp>
+        <p:nvSpPr>
+          <p:cNvPr id="3" name="Subtitle 2"/>
+          <p:cNvSpPr>
+            <a:spLocks noGrp="1"/>
+          </p:cNvSpPr>
+          <p:nvPr>
+            <p:ph type="subTitle" idx="1"/>
+          </p:nvPr>
+        </p:nvSpPr>
+        <p:spPr>
+          <a:xfrm>
+            <a:off x="1080060" y="4069113"/>
+            <a:ext cx="7315200" cy="914400"/>
+          </a:xfrm>
+        </p:spPr>
+        <p:txBody>
+          <a:bodyPr>
+            <a:normAutofit/>
+          </a:bodyPr>
+          <a:lstStyle/>
+          <a:p>
+            <a:r>
+              <a:t>Targeting Deep Parser Logic and State Exhaustion in Snort </a:t>
+            </a:r>
+            <a:r>
+              <a:rPr lang="en-US"/>
+              <a:t>3</a:t>
+            </a:r>
+            <a:endParaRPr/>
+          </a:p>
+          <a:p>
+            <a:endParaRPr/>
+          </a:p>
+        </p:txBody>
+      </p:sp>
+      <p:sp>
+        <p:nvSpPr>
+          <p:cNvPr id="7" name="TextBox 6">
             <a:extLst>
               <a:ext uri="{FF2B5EF4-FFF2-40B4-BE49-F238E27FC236}">
-                <a16:creationId xmlns:a16="http://schemas.microsoft.com/office/drawing/2014/main" id="{C55857FD-294A-3FBB-9525-4755BCD91B23}"/>
+                <a16:creationId xmlns:a16="http://schemas.microsoft.com/office/drawing/2014/main" id="{C3656CA5-00C7-A43B-4330-84AA3E4A177D}"/>
               </a:ext>
             </a:extLst>
           </p:cNvPr>
-          <p:cNvSpPr>
-            <a:spLocks noGrp="1"/>
-          </p:cNvSpPr>
-          <p:nvPr>
-            <p:ph type="ctrTitle"/>
-          </p:nvPr>
-        </p:nvSpPr>
-        <p:spPr/>
-        <p:txBody>
-          <a:bodyPr/>
-          <a:lstStyle/>
-          <a:p>
-            <a:endParaRPr lang="en-US"/>
-          </a:p>
-        </p:txBody>
-      </p:sp>
-      <p:sp>
-        <p:nvSpPr>
-          <p:cNvPr id="3" name="Subtitle 2">
+          <p:cNvSpPr txBox="1"/>
+          <p:nvPr/>
+        </p:nvSpPr>
+        <p:spPr>
+          <a:xfrm>
+            <a:off x="6460066" y="4428067"/>
+            <a:ext cx="2144433" cy="369332"/>
+          </a:xfrm>
+          <a:prstGeom prst="rect">
+            <a:avLst/>
+          </a:prstGeom>
+          <a:noFill/>
+        </p:spPr>
+        <p:txBody>
+          <a:bodyPr wrap="none" rtlCol="0">
+            <a:spAutoFit/>
+          </a:bodyPr>
+          <a:lstStyle/>
+          <a:p>
+            <a:r>
+              <a:rPr lang="en-US">
+                <a:solidFill>
+                  <a:srgbClr val="DAF1F6"/>
+                </a:solidFill>
+              </a:rPr>
+              <a:t>-Soumyajeet Ghatak</a:t>
+            </a:r>
+          </a:p>
+        </p:txBody>
+      </p:sp>
+      <p:sp>
+        <p:nvSpPr>
+          <p:cNvPr id="8" name="TextBox 7">
             <a:extLst>
               <a:ext uri="{FF2B5EF4-FFF2-40B4-BE49-F238E27FC236}">
-                <a16:creationId xmlns:a16="http://schemas.microsoft.com/office/drawing/2014/main" id="{10442655-A28F-711B-CED2-13AC6ED2CA73}"/>
+                <a16:creationId xmlns:a16="http://schemas.microsoft.com/office/drawing/2014/main" id="{2806BC87-3187-4050-9E6C-C76D0374B230}"/>
               </a:ext>
             </a:extLst>
           </p:cNvPr>
-          <p:cNvSpPr>
-            <a:spLocks noGrp="1"/>
-          </p:cNvSpPr>
-          <p:nvPr>
-            <p:ph type="subTitle" idx="1"/>
-          </p:nvPr>
-        </p:nvSpPr>
-        <p:spPr/>
-        <p:txBody>
-          <a:bodyPr/>
+          <p:cNvSpPr txBox="1"/>
+          <p:nvPr/>
+        </p:nvSpPr>
+        <p:spPr>
+          <a:xfrm>
+            <a:off x="7315200" y="4706514"/>
+            <a:ext cx="1289299" cy="276999"/>
+          </a:xfrm>
+          <a:prstGeom prst="rect">
+            <a:avLst/>
+          </a:prstGeom>
+          <a:noFill/>
+        </p:spPr>
+        <p:txBody>
+          <a:bodyPr wrap="square" rtlCol="0">
+            <a:spAutoFit/>
+          </a:bodyPr>
+          <a:lstStyle/>
+          <a:p>
+            <a:r>
+              <a:rPr lang="en-US" sz="1200">
+                <a:solidFill>
+                  <a:srgbClr val="DAF1F6"/>
+                </a:solidFill>
+              </a:rPr>
+              <a:t>Technical Intern I</a:t>
+            </a:r>
+          </a:p>
+        </p:txBody>
+      </p:sp>
+      <p:sp>
+        <p:nvSpPr>
+          <p:cNvPr id="11" name="TextBox 10">
+            <a:extLst>
+              <a:ext uri="{FF2B5EF4-FFF2-40B4-BE49-F238E27FC236}">
+                <a16:creationId xmlns:a16="http://schemas.microsoft.com/office/drawing/2014/main" id="{C54F851E-D22D-A5A3-F6C1-4CBFB9542636}"/>
+              </a:ext>
+            </a:extLst>
+          </p:cNvPr>
+          <p:cNvSpPr txBox="1"/>
+          <p:nvPr/>
+        </p:nvSpPr>
+        <p:spPr>
+          <a:xfrm>
+            <a:off x="1794933" y="1583267"/>
+            <a:ext cx="184731" cy="369332"/>
+          </a:xfrm>
+          <a:prstGeom prst="rect">
+            <a:avLst/>
+          </a:prstGeom>
+          <a:noFill/>
+        </p:spPr>
+        <p:txBody>
+          <a:bodyPr wrap="none" rtlCol="0">
+            <a:spAutoFit/>
+          </a:bodyPr>
           <a:lstStyle/>
           <a:p>
             <a:endParaRPr lang="en-US"/>
-          </a:p>
-        </p:txBody>
-      </p:sp>
-    </p:spTree>
-    <p:extLst>
-      <p:ext uri="{BB962C8B-B14F-4D97-AF65-F5344CB8AC3E}">
-        <p14:creationId xmlns:p14="http://schemas.microsoft.com/office/powerpoint/2010/main" val="1625404280"/>
-      </p:ext>
-    </p:extLst>
-  </p:cSld>
-  <p:clrMapOvr>
-    <a:masterClrMapping/>
-  </p:clrMapOvr>
-</p:sld>
-</file>
-
-<file path=ppt/slides/slide10.xml><?xml version="1.0" encoding="utf-8"?>
-<p:sld xmlns:a="http://schemas.openxmlformats.org/drawingml/2006/main" xmlns:p="http://schemas.openxmlformats.org/presentationml/2006/main" xmlns:r="http://schemas.openxmlformats.org/officeDocument/2006/relationships">
-  <p:cSld>
-    <p:spTree>
-      <p:nvGrpSpPr>
-        <p:cNvPr id="1" name=""/>
-        <p:cNvGrpSpPr/>
-        <p:nvPr/>
-      </p:nvGrpSpPr>
-      <p:grpSpPr/>
-      <p:sp>
-        <p:nvSpPr>
-          <p:cNvPr id="2" name="Title 1"/>
-          <p:cNvSpPr>
-            <a:spLocks noGrp="1"/>
-          </p:cNvSpPr>
-          <p:nvPr>
-            <p:ph type="title"/>
-          </p:nvPr>
-        </p:nvSpPr>
-        <p:spPr/>
-        <p:txBody>
-          <a:bodyPr/>
-          <a:lstStyle/>
-          <a:p>
-            <a:r>
-              <a:t>Conclusion &amp; Future Work</a:t>
-            </a:r>
-          </a:p>
-        </p:txBody>
-      </p:sp>
-      <p:sp>
-        <p:nvSpPr>
-          <p:cNvPr id="3" name="Content Placeholder 2"/>
-          <p:cNvSpPr>
-            <a:spLocks noGrp="1"/>
-          </p:cNvSpPr>
-          <p:nvPr>
-            <p:ph idx="1"/>
-          </p:nvPr>
-        </p:nvSpPr>
-        <p:spPr/>
-        <p:txBody>
-          <a:bodyPr/>
-          <a:lstStyle/>
-          <a:p>
-            <a:pPr/>
-            <a:r>
-              <a:t>Results: Built a highly resilient, deadlock-free protocol fuzzer capable of sustained million-packet execution loops.</a:t>
-            </a:r>
-          </a:p>
-          <a:p>
-            <a:pPr/>
-            <a:r>
-              <a:t>Next Steps:</a:t>
-            </a:r>
-          </a:p>
-          <a:p>
-            <a:pPr lvl="1"/>
-            <a:r>
-              <a:t>Leave the fuzzer running for extended multi-hour campaigns to let ASan catch deep memory leaks.</a:t>
-            </a:r>
-          </a:p>
-          <a:p>
-            <a:pPr lvl="1"/>
-            <a:r>
-              <a:t>Extend the generator to target other complex application-layer protocols (e.g., HTTP/2, TLS handshakes).</a:t>
-            </a:r>
-          </a:p>
-          <a:p>
-            <a:pPr lvl="1"/>
-            <a:r>
-              <a:t>Implement coverage-guided feedback (e.g., connecting it to AFL++).</a:t>
-            </a:r>
           </a:p>
         </p:txBody>
       </p:sp>
@@ -3591,7 +3639,7 @@
 </file>
 
 <file path=ppt/slides/slide2.xml><?xml version="1.0" encoding="utf-8"?>
-<p:sld xmlns:a="http://schemas.openxmlformats.org/drawingml/2006/main" xmlns:p="http://schemas.openxmlformats.org/presentationml/2006/main" xmlns:r="http://schemas.openxmlformats.org/officeDocument/2006/relationships">
+<p:sld xmlns:a="http://schemas.openxmlformats.org/drawingml/2006/main" xmlns:r="http://schemas.openxmlformats.org/officeDocument/2006/relationships" xmlns:p="http://schemas.openxmlformats.org/presentationml/2006/main">
   <p:cSld>
     <p:spTree>
       <p:nvGrpSpPr>
@@ -3599,7 +3647,14 @@
         <p:cNvGrpSpPr/>
         <p:nvPr/>
       </p:nvGrpSpPr>
-      <p:grpSpPr/>
+      <p:grpSpPr>
+        <a:xfrm>
+          <a:off x="0" y="0"/>
+          <a:ext cx="0" cy="0"/>
+          <a:chOff x="0" y="0"/>
+          <a:chExt cx="0" cy="0"/>
+        </a:xfrm>
+      </p:grpSpPr>
       <p:sp>
         <p:nvSpPr>
           <p:cNvPr id="2" name="Title 1"/>
@@ -3607,43 +3662,77 @@
             <a:spLocks noGrp="1"/>
           </p:cNvSpPr>
           <p:nvPr>
-            <p:ph type="ctrTitle"/>
-          </p:nvPr>
-        </p:nvSpPr>
-        <p:spPr/>
-        <p:txBody>
-          <a:bodyPr/>
-          <a:lstStyle/>
-          <a:p>
-            <a:r>
-              <a:t>Advanced Protocol Fuzzing for Intrusion Detection Systems</a:t>
-            </a:r>
-          </a:p>
-        </p:txBody>
-      </p:sp>
-      <p:sp>
-        <p:nvSpPr>
-          <p:cNvPr id="3" name="Subtitle 2"/>
-          <p:cNvSpPr>
-            <a:spLocks noGrp="1"/>
-          </p:cNvSpPr>
-          <p:nvPr>
-            <p:ph type="subTitle" idx="1"/>
-          </p:nvPr>
-        </p:nvSpPr>
-        <p:spPr/>
-        <p:txBody>
-          <a:bodyPr/>
-          <a:lstStyle/>
-          <a:p>
-            <a:r>
-              <a:t>Targeting Deep Parser Logic and State Exhaustion in Snort 3</a:t>
-            </a:r>
-          </a:p>
-          <a:p/>
-          <a:p>
-            <a:r>
-              <a:t>Generated by Protocol Fuzzer</a:t>
+            <p:ph type="title"/>
+          </p:nvPr>
+        </p:nvSpPr>
+        <p:spPr/>
+        <p:txBody>
+          <a:bodyPr/>
+          <a:lstStyle/>
+          <a:p>
+            <a:r>
+              <a:t>Project Objective</a:t>
+            </a:r>
+          </a:p>
+        </p:txBody>
+      </p:sp>
+      <p:sp>
+        <p:nvSpPr>
+          <p:cNvPr id="3" name="Content Placeholder 2"/>
+          <p:cNvSpPr>
+            <a:spLocks noGrp="1"/>
+          </p:cNvSpPr>
+          <p:nvPr>
+            <p:ph idx="1"/>
+          </p:nvPr>
+        </p:nvSpPr>
+        <p:spPr/>
+        <p:txBody>
+          <a:bodyPr/>
+          <a:lstStyle/>
+          <a:p>
+            <a:r>
+              <a:t>Goal: Design and implement a custom, high-performance protocol fuzzer to uncover memory corruption and logical vulnerabilities in Snort 3.</a:t>
+            </a:r>
+          </a:p>
+          <a:p>
+            <a:r>
+              <a:t>Target Areas:</a:t>
+            </a:r>
+          </a:p>
+          <a:p>
+            <a:pPr lvl="1"/>
+            <a:r>
+              <a:t>Algorithmic Complexity &amp; Infinite Recursion.</a:t>
+            </a:r>
+          </a:p>
+          <a:p>
+            <a:pPr lvl="1"/>
+            <a:r>
+              <a:t>Memory Leak Amplification &amp; State Exhaustion.</a:t>
+            </a:r>
+          </a:p>
+          <a:p>
+            <a:pPr lvl="1"/>
+            <a:r>
+              <a:t>Deep Parser Vulnerabilities (Out-of-bounds reads, heap overflows).</a:t>
+            </a:r>
+          </a:p>
+          <a:p>
+            <a:r>
+              <a:t>Approach:</a:t>
+            </a:r>
+          </a:p>
+          <a:p>
+            <a:pPr lvl="1"/>
+            <a:r>
+              <a:t>Target a custom Snort 3 build instrumented with AddressSanitizer (ASan).</a:t>
+            </a:r>
+          </a:p>
+          <a:p>
+            <a:pPr lvl="1"/>
+            <a:r>
+              <a:t>Inject raw, malformed PCAP streams directly into Snort's inspection engine.</a:t>
             </a:r>
           </a:p>
         </p:txBody>
@@ -3657,7 +3746,7 @@
 </file>
 
 <file path=ppt/slides/slide3.xml><?xml version="1.0" encoding="utf-8"?>
-<p:sld xmlns:a="http://schemas.openxmlformats.org/drawingml/2006/main" xmlns:p="http://schemas.openxmlformats.org/presentationml/2006/main" xmlns:r="http://schemas.openxmlformats.org/officeDocument/2006/relationships">
+<p:sld xmlns:a="http://schemas.openxmlformats.org/drawingml/2006/main" xmlns:r="http://schemas.openxmlformats.org/officeDocument/2006/relationships" xmlns:p="http://schemas.openxmlformats.org/presentationml/2006/main">
   <p:cSld>
     <p:spTree>
       <p:nvGrpSpPr>
@@ -3665,7 +3754,14 @@
         <p:cNvGrpSpPr/>
         <p:nvPr/>
       </p:nvGrpSpPr>
-      <p:grpSpPr/>
+      <p:grpSpPr>
+        <a:xfrm>
+          <a:off x="0" y="0"/>
+          <a:ext cx="0" cy="0"/>
+          <a:chOff x="0" y="0"/>
+          <a:chExt cx="0" cy="0"/>
+        </a:xfrm>
+      </p:grpSpPr>
       <p:sp>
         <p:nvSpPr>
           <p:cNvPr id="2" name="Title 1"/>
@@ -3682,7 +3778,7 @@
           <a:lstStyle/>
           <a:p>
             <a:r>
-              <a:t>Project Objective</a:t>
+              <a:t>Fuzzer Architecture</a:t>
             </a:r>
           </a:p>
         </p:txBody>
@@ -3702,51 +3798,23 @@
           <a:bodyPr/>
           <a:lstStyle/>
           <a:p>
-            <a:pPr/>
-            <a:r>
-              <a:t>Goal: Design and implement a custom, high-performance protocol fuzzer to uncover memory corruption and logical vulnerabilities in Snort 3.</a:t>
-            </a:r>
-          </a:p>
-          <a:p>
-            <a:pPr/>
-            <a:r>
-              <a:t>Target Areas:</a:t>
-            </a:r>
-          </a:p>
-          <a:p>
-            <a:pPr lvl="1"/>
-            <a:r>
-              <a:t>Algorithmic Complexity &amp; Infinite Recursion.</a:t>
-            </a:r>
-          </a:p>
-          <a:p>
-            <a:pPr lvl="1"/>
-            <a:r>
-              <a:t>Memory Leak Amplification &amp; State Exhaustion.</a:t>
-            </a:r>
-          </a:p>
-          <a:p>
-            <a:pPr lvl="1"/>
-            <a:r>
-              <a:t>Deep Parser Vulnerabilities (Out-of-bounds reads, heap overflows).</a:t>
-            </a:r>
-          </a:p>
-          <a:p>
-            <a:pPr/>
-            <a:r>
-              <a:t>Approach:</a:t>
-            </a:r>
-          </a:p>
-          <a:p>
-            <a:pPr lvl="1"/>
-            <a:r>
-              <a:t>Target a custom Snort 3 build instrumented with AddressSanitizer (ASan).</a:t>
-            </a:r>
-          </a:p>
-          <a:p>
-            <a:pPr lvl="1"/>
-            <a:r>
-              <a:t>Inject raw, malformed PCAP streams directly into Snort's inspection engine.</a:t>
+            <a:r>
+              <a:t>Generator Engine: Crafts raw DNS wire-format packets from scratch instead of relying on standard network libraries, allowing intentional RFC violations.</a:t>
+            </a:r>
+          </a:p>
+          <a:p>
+            <a:r>
+              <a:t>Mutation Engine: Uses weighted strategy rotation to balance between surface-level bit-flips and deep logical anomalies.</a:t>
+            </a:r>
+          </a:p>
+          <a:p>
+            <a:r>
+              <a:t>Transport Layer: Wraps payloads in synthetic Ethernet/IPv4/UDP headers and writes them to a POSIX named pipe mimicking a live network stream.</a:t>
+            </a:r>
+          </a:p>
+          <a:p>
+            <a:r>
+              <a:t>Watchdog Monitor: A background thread that tracks process health, detects hangs, and monitors for RAM bloat.</a:t>
             </a:r>
           </a:p>
         </p:txBody>
@@ -3760,7 +3828,7 @@
 </file>
 
 <file path=ppt/slides/slide4.xml><?xml version="1.0" encoding="utf-8"?>
-<p:sld xmlns:a="http://schemas.openxmlformats.org/drawingml/2006/main" xmlns:p="http://schemas.openxmlformats.org/presentationml/2006/main" xmlns:r="http://schemas.openxmlformats.org/officeDocument/2006/relationships">
+<p:sld xmlns:a="http://schemas.openxmlformats.org/drawingml/2006/main" xmlns:r="http://schemas.openxmlformats.org/officeDocument/2006/relationships" xmlns:p="http://schemas.openxmlformats.org/presentationml/2006/main">
   <p:cSld>
     <p:spTree>
       <p:nvGrpSpPr>
@@ -3768,7 +3836,14 @@
         <p:cNvGrpSpPr/>
         <p:nvPr/>
       </p:nvGrpSpPr>
-      <p:grpSpPr/>
+      <p:grpSpPr>
+        <a:xfrm>
+          <a:off x="0" y="0"/>
+          <a:ext cx="0" cy="0"/>
+          <a:chOff x="0" y="0"/>
+          <a:chExt cx="0" cy="0"/>
+        </a:xfrm>
+      </p:grpSpPr>
       <p:sp>
         <p:nvSpPr>
           <p:cNvPr id="2" name="Title 1"/>
@@ -3785,7 +3860,7 @@
           <a:lstStyle/>
           <a:p>
             <a:r>
-              <a:t>Fuzzer Architecture</a:t>
+              <a:t>Attack Vector 1 - Algorithmic Complexity</a:t>
             </a:r>
           </a:p>
         </p:txBody>
@@ -3805,27 +3880,36 @@
           <a:bodyPr/>
           <a:lstStyle/>
           <a:p>
-            <a:pPr/>
-            <a:r>
-              <a:t>Generator Engine: Crafts raw DNS wire-format packets from scratch instead of relying on standard network libraries, allowing intentional RFC violations.</a:t>
-            </a:r>
-          </a:p>
-          <a:p>
-            <a:pPr/>
-            <a:r>
-              <a:t>Mutation Engine: Uses weighted strategy rotation to balance between surface-level bit-flips and deep logical anomalies.</a:t>
-            </a:r>
-          </a:p>
-          <a:p>
-            <a:pPr/>
-            <a:r>
-              <a:t>Transport Layer: Wraps payloads in synthetic Ethernet/IPv4/UDP headers and writes them to a POSIX named pipe mimicking a live network stream.</a:t>
-            </a:r>
-          </a:p>
-          <a:p>
-            <a:pPr/>
-            <a:r>
-              <a:t>Watchdog Monitor: A background thread that tracks process health, detects hangs, and monitors for RAM bloat.</a:t>
+            <a:r>
+              <a:t>The Theory: IDS engines must parse nested structures. If parsing loops aren't strictly bounded, CPU cycles can be exhausted.</a:t>
+            </a:r>
+          </a:p>
+          <a:p>
+            <a:r>
+              <a:t>Compression Pointer Loops:</a:t>
+            </a:r>
+          </a:p>
+          <a:p>
+            <a:pPr lvl="1"/>
+            <a:r>
+              <a:t>Crafted DNS pointers that reference themselves (self_ref), reference each other (mutual), or create long cyclic chains.</a:t>
+            </a:r>
+          </a:p>
+          <a:p>
+            <a:pPr lvl="1"/>
+            <a:r>
+              <a:t>Goal: Trigger infinite recursion in Snort's name decoder.</a:t>
+            </a:r>
+          </a:p>
+          <a:p>
+            <a:r>
+              <a:t>Label Flooding:</a:t>
+            </a:r>
+          </a:p>
+          <a:p>
+            <a:pPr lvl="1"/>
+            <a:r>
+              <a:t>Generated DNS queries with 200+ single-byte labels to stress iteration limits.</a:t>
             </a:r>
           </a:p>
         </p:txBody>
@@ -3839,7 +3923,7 @@
 </file>
 
 <file path=ppt/slides/slide5.xml><?xml version="1.0" encoding="utf-8"?>
-<p:sld xmlns:a="http://schemas.openxmlformats.org/drawingml/2006/main" xmlns:p="http://schemas.openxmlformats.org/presentationml/2006/main" xmlns:r="http://schemas.openxmlformats.org/officeDocument/2006/relationships">
+<p:sld xmlns:a="http://schemas.openxmlformats.org/drawingml/2006/main" xmlns:r="http://schemas.openxmlformats.org/officeDocument/2006/relationships" xmlns:p="http://schemas.openxmlformats.org/presentationml/2006/main">
   <p:cSld>
     <p:spTree>
       <p:nvGrpSpPr>
@@ -3847,7 +3931,14 @@
         <p:cNvGrpSpPr/>
         <p:nvPr/>
       </p:nvGrpSpPr>
-      <p:grpSpPr/>
+      <p:grpSpPr>
+        <a:xfrm>
+          <a:off x="0" y="0"/>
+          <a:ext cx="0" cy="0"/>
+          <a:chOff x="0" y="0"/>
+          <a:chExt cx="0" cy="0"/>
+        </a:xfrm>
+      </p:grpSpPr>
       <p:sp>
         <p:nvSpPr>
           <p:cNvPr id="2" name="Title 1"/>
@@ -3864,7 +3955,7 @@
           <a:lstStyle/>
           <a:p>
             <a:r>
-              <a:t>Attack Vector 1 - Algorithmic Complexity</a:t>
+              <a:t>Attack Vector 2 - State Exhaustion</a:t>
             </a:r>
           </a:p>
         </p:txBody>
@@ -3884,39 +3975,36 @@
           <a:bodyPr/>
           <a:lstStyle/>
           <a:p>
-            <a:pPr/>
-            <a:r>
-              <a:t>The Theory: IDS engines must parse nested structures. If parsing loops aren't strictly bounded, CPU cycles can be exhausted.</a:t>
-            </a:r>
-          </a:p>
-          <a:p>
-            <a:pPr/>
-            <a:r>
-              <a:t>Compression Pointer Loops:</a:t>
+            <a:r>
+              <a:t>The Theory: Snort tracks connection states. By spoofing millions of unique connections, we can exhaust the flow table and trigger memory leaks.</a:t>
+            </a:r>
+          </a:p>
+          <a:p>
+            <a:r>
+              <a:t>Implementation:</a:t>
             </a:r>
           </a:p>
           <a:p>
             <a:pPr lvl="1"/>
             <a:r>
-              <a:t>Crafted DNS pointers that reference themselves (self_ref), reference each other (mutual), or create long cyclic chains.</a:t>
+              <a:t>Randomized the 5-tuple (Source IP, Destination IP, Source Port, Destination Port, Protocol) for every injected packet.</a:t>
+            </a:r>
+          </a:p>
+          <a:p>
+            <a:r>
+              <a:t>The Breakthrough:</a:t>
             </a:r>
           </a:p>
           <a:p>
             <a:pPr lvl="1"/>
             <a:r>
-              <a:t>Goal: Trigger infinite recursion in Snort's name decoder.</a:t>
-            </a:r>
-          </a:p>
-          <a:p>
-            <a:pPr/>
-            <a:r>
-              <a:t>Label Flooding:</a:t>
+              <a:t>Synchronized synthetic PCAP timestamps with real wall-clock time.</a:t>
             </a:r>
           </a:p>
           <a:p>
             <a:pPr lvl="1"/>
             <a:r>
-              <a:t>Generated DNS queries with 200+ single-byte labels to stress iteration limits.</a:t>
+              <a:t>This forced Snort's internal session clock to advance, properly accumulating parallel sessions until timeouts fired.</a:t>
             </a:r>
           </a:p>
         </p:txBody>
@@ -3930,7 +4018,7 @@
 </file>
 
 <file path=ppt/slides/slide6.xml><?xml version="1.0" encoding="utf-8"?>
-<p:sld xmlns:a="http://schemas.openxmlformats.org/drawingml/2006/main" xmlns:p="http://schemas.openxmlformats.org/presentationml/2006/main" xmlns:r="http://schemas.openxmlformats.org/officeDocument/2006/relationships">
+<p:sld xmlns:a="http://schemas.openxmlformats.org/drawingml/2006/main" xmlns:r="http://schemas.openxmlformats.org/officeDocument/2006/relationships" xmlns:p="http://schemas.openxmlformats.org/presentationml/2006/main">
   <p:cSld>
     <p:spTree>
       <p:nvGrpSpPr>
@@ -3938,7 +4026,14 @@
         <p:cNvGrpSpPr/>
         <p:nvPr/>
       </p:nvGrpSpPr>
-      <p:grpSpPr/>
+      <p:grpSpPr>
+        <a:xfrm>
+          <a:off x="0" y="0"/>
+          <a:ext cx="0" cy="0"/>
+          <a:chOff x="0" y="0"/>
+          <a:chExt cx="0" cy="0"/>
+        </a:xfrm>
+      </p:grpSpPr>
       <p:sp>
         <p:nvSpPr>
           <p:cNvPr id="2" name="Title 1"/>
@@ -3955,7 +4050,7 @@
           <a:lstStyle/>
           <a:p>
             <a:r>
-              <a:t>Attack Vector 2 - State Exhaustion</a:t>
+              <a:t>Attack Vector 3 - Deep Parser Fuzzing</a:t>
             </a:r>
           </a:p>
         </p:txBody>
@@ -3975,39 +4070,37 @@
           <a:bodyPr/>
           <a:lstStyle/>
           <a:p>
-            <a:pPr/>
-            <a:r>
-              <a:t>The Theory: Snort tracks connection states. By spoofing millions of unique connections, we can exhaust the flow table and trigger memory leaks.</a:t>
-            </a:r>
-          </a:p>
-          <a:p>
-            <a:pPr/>
-            <a:r>
-              <a:t>Implementation:</a:t>
+            <a:r>
+              <a:t>The Shift: Standard DNS queries (QR=0) are heavily tested. The real complexity lies in DNS responses (QR=1).</a:t>
+            </a:r>
+          </a:p>
+          <a:p>
+            <a:r>
+              <a:t>Targeted Anomalies:</a:t>
             </a:r>
           </a:p>
           <a:p>
             <a:pPr lvl="1"/>
             <a:r>
-              <a:t>Randomized the 5-tuple (Source IP, Destination IP, Source Port, Destination Port, Protocol) for every injected packet.</a:t>
-            </a:r>
-          </a:p>
-          <a:p>
-            <a:pPr/>
-            <a:r>
-              <a:t>The Breakthrough:</a:t>
+              <a:t>RDLENGTH Mismatches: Claiming 512 bytes of data but sending 4 (Heap Buffer Overflows).</a:t>
             </a:r>
           </a:p>
           <a:p>
             <a:pPr lvl="1"/>
             <a:r>
-              <a:t>Synchronized synthetic PCAP timestamps with real wall-clock time.</a:t>
+              <a:t>CNAME Bad Pointers: Offsets pointing far beyond the packet boundary (Out-of-Bounds Reads).</a:t>
             </a:r>
           </a:p>
           <a:p>
             <a:pPr lvl="1"/>
             <a:r>
-              <a:t>This forced Snort's internal session clock to advance, properly accumulating parallel sessions until timeouts fired.</a:t>
+              <a:t>Count Mismatches: Header claims 20 answer records, but only 1 exists.</a:t>
+            </a:r>
+          </a:p>
+          <a:p>
+            <a:pPr lvl="1"/>
+            <a:r>
+              <a:t>Overlapping Records: Compression pointers that land maliciously inside the data payload of previous records.</a:t>
             </a:r>
           </a:p>
         </p:txBody>
@@ -4021,7 +4114,7 @@
 </file>
 
 <file path=ppt/slides/slide7.xml><?xml version="1.0" encoding="utf-8"?>
-<p:sld xmlns:a="http://schemas.openxmlformats.org/drawingml/2006/main" xmlns:p="http://schemas.openxmlformats.org/presentationml/2006/main" xmlns:r="http://schemas.openxmlformats.org/officeDocument/2006/relationships">
+<p:sld xmlns:a="http://schemas.openxmlformats.org/drawingml/2006/main" xmlns:r="http://schemas.openxmlformats.org/officeDocument/2006/relationships" xmlns:p="http://schemas.openxmlformats.org/presentationml/2006/main">
   <p:cSld>
     <p:spTree>
       <p:nvGrpSpPr>
@@ -4029,7 +4122,14 @@
         <p:cNvGrpSpPr/>
         <p:nvPr/>
       </p:nvGrpSpPr>
-      <p:grpSpPr/>
+      <p:grpSpPr>
+        <a:xfrm>
+          <a:off x="0" y="0"/>
+          <a:ext cx="0" cy="0"/>
+          <a:chOff x="0" y="0"/>
+          <a:chExt cx="0" cy="0"/>
+        </a:xfrm>
+      </p:grpSpPr>
       <p:sp>
         <p:nvSpPr>
           <p:cNvPr id="2" name="Title 1"/>
@@ -4046,7 +4146,7 @@
           <a:lstStyle/>
           <a:p>
             <a:r>
-              <a:t>Attack Vector 3 - Deep Parser Fuzzing</a:t>
+              <a:t>Process Lifecycle &amp; Crash Detection</a:t>
             </a:r>
           </a:p>
         </p:txBody>
@@ -4066,39 +4166,43 @@
           <a:bodyPr/>
           <a:lstStyle/>
           <a:p>
-            <a:pPr/>
-            <a:r>
-              <a:t>The Shift: Standard DNS queries (QR=0) are heavily tested. The real complexity lies in DNS responses (QR=1).</a:t>
-            </a:r>
-          </a:p>
-          <a:p>
-            <a:pPr/>
-            <a:r>
-              <a:t>Targeted Anomalies:</a:t>
+            <a:r>
+              <a:t>Overcoming Pipe Deadlocks:</a:t>
             </a:r>
           </a:p>
           <a:p>
             <a:pPr lvl="1"/>
             <a:r>
-              <a:t>RDLENGTH Mismatches: Claiming 512 bytes of data but sending 4 (Heap Buffer Overflows).</a:t>
+              <a:t>Standard stdout/stderr pipes have a 64KB kernel limit. Snort output was deadlocking the fuzzer.</a:t>
             </a:r>
           </a:p>
           <a:p>
             <a:pPr lvl="1"/>
             <a:r>
-              <a:t>CNAME Bad Pointers: Offsets pointing far beyond the packet boundary (Out-of-Bounds Reads).</a:t>
+              <a:t>Solution: Redirected stdout to /dev/null and implemented a background thread to continuously drain stderr.</a:t>
+            </a:r>
+          </a:p>
+          <a:p>
+            <a:r>
+              <a:t>Crash Logging:</a:t>
             </a:r>
           </a:p>
           <a:p>
             <a:pPr lvl="1"/>
             <a:r>
-              <a:t>Count Mismatches: Header claims 20 answer records, but only 1 exists.</a:t>
+              <a:t>When Snort crashes, the fuzzer catches the exit code.</a:t>
             </a:r>
           </a:p>
           <a:p>
             <a:pPr lvl="1"/>
             <a:r>
-              <a:t>Overlapping Records: Compression pointers that land maliciously inside the data payload of previous records.</a:t>
+              <a:t>Extracts the AddressSanitizer (ASan) stack trace from the drained stderr.</a:t>
+            </a:r>
+          </a:p>
+          <a:p>
+            <a:pPr lvl="1"/>
+            <a:r>
+              <a:t>Saves a detailed report mapping the crash back to the exact iteration and fuzzing strategy.</a:t>
             </a:r>
           </a:p>
         </p:txBody>
@@ -4112,7 +4216,7 @@
 </file>
 
 <file path=ppt/slides/slide8.xml><?xml version="1.0" encoding="utf-8"?>
-<p:sld xmlns:a="http://schemas.openxmlformats.org/drawingml/2006/main" xmlns:p="http://schemas.openxmlformats.org/presentationml/2006/main" xmlns:r="http://schemas.openxmlformats.org/officeDocument/2006/relationships">
+<p:sld xmlns:a="http://schemas.openxmlformats.org/drawingml/2006/main" xmlns:r="http://schemas.openxmlformats.org/officeDocument/2006/relationships" xmlns:p="http://schemas.openxmlformats.org/presentationml/2006/main">
   <p:cSld>
     <p:spTree>
       <p:nvGrpSpPr>
@@ -4120,7 +4224,14 @@
         <p:cNvGrpSpPr/>
         <p:nvPr/>
       </p:nvGrpSpPr>
-      <p:grpSpPr/>
+      <p:grpSpPr>
+        <a:xfrm>
+          <a:off x="0" y="0"/>
+          <a:ext cx="0" cy="0"/>
+          <a:chOff x="0" y="0"/>
+          <a:chExt cx="0" cy="0"/>
+        </a:xfrm>
+      </p:grpSpPr>
       <p:sp>
         <p:nvSpPr>
           <p:cNvPr id="2" name="Title 1"/>
@@ -4137,7 +4248,7 @@
           <a:lstStyle/>
           <a:p>
             <a:r>
-              <a:t>Process Lifecycle &amp; Crash Detection</a:t>
+              <a:t>Key Challenges &amp; Engineering Solutions</a:t>
             </a:r>
           </a:p>
         </p:txBody>
@@ -4157,45 +4268,37 @@
           <a:bodyPr/>
           <a:lstStyle/>
           <a:p>
-            <a:pPr/>
-            <a:r>
-              <a:t>Overcoming Pipe Deadlocks:</a:t>
+            <a:r>
+              <a:t>Challenge 1: Live Injection on macOS (lo0 loopback).</a:t>
             </a:r>
           </a:p>
           <a:p>
             <a:pPr lvl="1"/>
             <a:r>
-              <a:t>Standard stdout/stderr pipes have a 64KB kernel limit. Snort output was deadlocking the fuzzer.</a:t>
+              <a:t>Issue: macOS loopback uses DLT_NULL, which Snort's DAQ does not support by default.</a:t>
             </a:r>
           </a:p>
           <a:p>
             <a:pPr lvl="1"/>
             <a:r>
-              <a:t>Solution: Redirected stdout to /dev/null and implemented a background thread to continuously drain stderr.</a:t>
-            </a:r>
-          </a:p>
-          <a:p>
-            <a:pPr/>
-            <a:r>
-              <a:t>Crash Logging:</a:t>
+              <a:t>Solution: Engineered a synthetic PCAP pipe wrapper that injects packets as standard Ethernet (DLT_EN10MB) without needing root privileges.</a:t>
+            </a:r>
+          </a:p>
+          <a:p>
+            <a:r>
+              <a:t>Challenge 2: Snort discarding packets without tracking state.</a:t>
             </a:r>
           </a:p>
           <a:p>
             <a:pPr lvl="1"/>
             <a:r>
-              <a:t>When Snort crashes, the fuzzer catches the exit code.</a:t>
+              <a:t>Issue: PCAP packets initially had 0, 0 for timestamps, keeping Snort frozen at epoch time.</a:t>
             </a:r>
           </a:p>
           <a:p>
             <a:pPr lvl="1"/>
             <a:r>
-              <a:t>Extracts the AddressSanitizer (ASan) stack trace from the drained stderr.</a:t>
-            </a:r>
-          </a:p>
-          <a:p>
-            <a:pPr lvl="1"/>
-            <a:r>
-              <a:t>Saves a detailed report mapping the crash back to the exact iteration and fuzzing strategy.</a:t>
+              <a:t>Solution: Injected dynamic microsecond-accurate timestamps into the PCAP record headers.</a:t>
             </a:r>
           </a:p>
         </p:txBody>
@@ -4209,7 +4312,7 @@
 </file>
 
 <file path=ppt/slides/slide9.xml><?xml version="1.0" encoding="utf-8"?>
-<p:sld xmlns:a="http://schemas.openxmlformats.org/drawingml/2006/main" xmlns:p="http://schemas.openxmlformats.org/presentationml/2006/main" xmlns:r="http://schemas.openxmlformats.org/officeDocument/2006/relationships">
+<p:sld xmlns:a="http://schemas.openxmlformats.org/drawingml/2006/main" xmlns:r="http://schemas.openxmlformats.org/officeDocument/2006/relationships" xmlns:p="http://schemas.openxmlformats.org/presentationml/2006/main">
   <p:cSld>
     <p:spTree>
       <p:nvGrpSpPr>
@@ -4217,7 +4320,14 @@
         <p:cNvGrpSpPr/>
         <p:nvPr/>
       </p:nvGrpSpPr>
-      <p:grpSpPr/>
+      <p:grpSpPr>
+        <a:xfrm>
+          <a:off x="0" y="0"/>
+          <a:ext cx="0" cy="0"/>
+          <a:chOff x="0" y="0"/>
+          <a:chExt cx="0" cy="0"/>
+        </a:xfrm>
+      </p:grpSpPr>
       <p:sp>
         <p:nvSpPr>
           <p:cNvPr id="2" name="Title 1"/>
@@ -4234,7 +4344,7 @@
           <a:lstStyle/>
           <a:p>
             <a:r>
-              <a:t>Key Challenges &amp; Engineering Solutions</a:t>
+              <a:t>Conclusion &amp; Future Work</a:t>
             </a:r>
           </a:p>
         </p:txBody>
@@ -4254,39 +4364,31 @@
           <a:bodyPr/>
           <a:lstStyle/>
           <a:p>
-            <a:pPr/>
-            <a:r>
-              <a:t>Challenge 1: Live Injection on macOS (lo0 loopback).</a:t>
+            <a:r>
+              <a:t>Results: Built a highly resilient, deadlock-free protocol fuzzer capable of sustained million-packet execution loops.</a:t>
+            </a:r>
+          </a:p>
+          <a:p>
+            <a:r>
+              <a:t>Next Steps:</a:t>
             </a:r>
           </a:p>
           <a:p>
             <a:pPr lvl="1"/>
             <a:r>
-              <a:t>Issue: macOS loopback uses DLT_NULL, which Snort's DAQ does not support by default.</a:t>
+              <a:t>Leave the fuzzer running for extended multi-hour campaigns to let ASan catch deep memory leaks.</a:t>
             </a:r>
           </a:p>
           <a:p>
             <a:pPr lvl="1"/>
             <a:r>
-              <a:t>Solution: Engineered a synthetic PCAP pipe wrapper that injects packets as standard Ethernet (DLT_EN10MB) without needing root privileges.</a:t>
-            </a:r>
-          </a:p>
-          <a:p>
-            <a:pPr/>
-            <a:r>
-              <a:t>Challenge 2: Snort discarding packets without tracking state.</a:t>
+              <a:t>Extend the generator to target other complex application-layer protocols (e.g., HTTP/2, TLS handshakes).</a:t>
             </a:r>
           </a:p>
           <a:p>
             <a:pPr lvl="1"/>
             <a:r>
-              <a:t>Issue: PCAP packets initially had 0, 0 for timestamps, keeping Snort frozen at epoch time.</a:t>
-            </a:r>
-          </a:p>
-          <a:p>
-            <a:pPr lvl="1"/>
-            <a:r>
-              <a:t>Solution: Injected dynamic microsecond-accurate timestamps into the PCAP record headers.</a:t>
+              <a:t>Implement coverage-guided feedback (e.g., connecting it to AFL++).</a:t>
             </a:r>
           </a:p>
         </p:txBody>

</xml_diff>